<commit_message>
Commit working-tree edits: IPR deck and Armour memo edits, dissertation one-pager, deck resave metadata
Co-Authored-By: Claude Fable 5 <noreply@anthropic.com>
</commit_message>
<xml_diff>
--- a/briefings/ipr-5min.pptx
+++ b/briefings/ipr-5min.pptx
@@ -4,6 +4,9 @@
   <p:sldMasterIdLst>
     <p:sldMasterId id="2147483648" r:id="rId1"/>
   </p:sldMasterIdLst>
+  <p:notesMasterIdLst>
+    <p:notesMasterId r:id="rId9"/>
+  </p:notesMasterIdLst>
   <p:sldIdLst>
     <p:sldId id="256" r:id="rId2"/>
     <p:sldId id="257" r:id="rId3"/>
@@ -13,9 +16,6 @@
     <p:sldId id="261" r:id="rId7"/>
     <p:sldId id="262" r:id="rId8"/>
   </p:sldIdLst>
-  <p:notesMasterIdLst>
-    <p:notesMasterId r:id="rId9"/>
-  </p:notesMasterIdLst>
   <p:sldSz cx="15544800" cy="10058400"/>
   <p:notesSz cx="10058400" cy="15544800"/>
   <p:defaultTextStyle>
@@ -110,6 +110,11 @@
       </a:defRPr>
     </a:lvl9pPr>
   </p:defaultTextStyle>
+  <p:extLst>
+    <p:ext uri="{EFAFB233-063F-42B5-8137-9DF3F51BA10A}">
+      <p15:sldGuideLst xmlns:p15="http://schemas.microsoft.com/office/powerpoint/2012/main"/>
+    </p:ext>
+  </p:extLst>
 </p:presentation>
 </file>
 
@@ -135,234 +140,10 @@
           <a:chExt cx="0" cy="0"/>
         </a:xfrm>
       </p:grpSpPr>
-      <p:sp>
-        <p:nvSpPr>
-          <p:cNvPr id="2" name="Header Placeholder 1"/>
-          <p:cNvSpPr>
-            <a:spLocks noGrp="1"/>
-          </p:cNvSpPr>
-          <p:nvPr>
-            <p:ph type="hdr" sz="quarter"/>
-          </p:nvPr>
-        </p:nvSpPr>
-        <p:spPr>
-          <a:xfrm>
-            <a:off x="0" y="0"/>
-            <a:ext cx="2971800" cy="458788"/>
-          </a:xfrm>
-          <a:prstGeom prst="rect">
-            <a:avLst/>
-          </a:prstGeom>
-        </p:spPr>
-        <p:txBody>
-          <a:bodyPr vert="horz" lIns="91440" tIns="45720" rIns="91440" bIns="45720" rtlCol="0"/>
-          <a:lstStyle>
-            <a:lvl1pPr algn="l">
-              <a:defRPr sz="1200"/>
-            </a:lvl1pPr>
-          </a:lstStyle>
-          <a:p>
-            <a:endParaRPr lang="en-US"/>
-          </a:p>
-        </p:txBody>
-      </p:sp>
-      <p:sp>
-        <p:nvSpPr>
-          <p:cNvPr id="3" name="Date Placeholder 2"/>
-          <p:cNvSpPr>
-            <a:spLocks noGrp="1"/>
-          </p:cNvSpPr>
-          <p:nvPr>
-            <p:ph type="dt" idx="1"/>
-          </p:nvPr>
-        </p:nvSpPr>
-        <p:spPr>
-          <a:xfrm>
-            <a:off x="3884613" y="0"/>
-            <a:ext cx="2971800" cy="458788"/>
-          </a:xfrm>
-          <a:prstGeom prst="rect">
-            <a:avLst/>
-          </a:prstGeom>
-        </p:spPr>
-        <p:txBody>
-          <a:bodyPr vert="horz" lIns="91440" tIns="45720" rIns="91440" bIns="45720" rtlCol="0"/>
-          <a:lstStyle>
-            <a:lvl1pPr algn="r">
-              <a:defRPr sz="1200"/>
-            </a:lvl1pPr>
-          </a:lstStyle>
-          <a:p>
-            <a:fld id="{5282F153-3F37-0F45-9E97-73ACFA13230C}" type="datetimeFigureOut">
-              <a:rPr lang="en-US"/>
-              <a:t>7/23/19</a:t>
-            </a:fld>
-            <a:endParaRPr lang="en-US"/>
-          </a:p>
-        </p:txBody>
-      </p:sp>
-      <p:sp>
-        <p:nvSpPr>
-          <p:cNvPr id="4" name="Slide Image Placeholder 3"/>
-          <p:cNvSpPr>
-            <a:spLocks noGrp="1" noRot="1" noChangeAspect="1"/>
-          </p:cNvSpPr>
-          <p:nvPr>
-            <p:ph type="sldImg" idx="2"/>
-          </p:nvPr>
-        </p:nvSpPr>
-        <p:spPr>
-          <a:xfrm>
-            <a:off x="685800" y="1143000"/>
-            <a:ext cx="5486400" cy="3086100"/>
-          </a:xfrm>
-          <a:prstGeom prst="rect">
-            <a:avLst/>
-          </a:prstGeom>
-          <a:noFill/>
-          <a:ln w="12700">
-            <a:solidFill>
-              <a:prstClr val="black"/>
-            </a:solidFill>
-          </a:ln>
-        </p:spPr>
-        <p:txBody>
-          <a:bodyPr vert="horz" lIns="91440" tIns="45720" rIns="91440" bIns="45720" rtlCol="0" anchor="ctr"/>
-          <a:lstStyle/>
-          <a:p>
-            <a:endParaRPr lang="en-US"/>
-          </a:p>
-        </p:txBody>
-      </p:sp>
-      <p:sp>
-        <p:nvSpPr>
-          <p:cNvPr id="5" name="Notes Placeholder 4"/>
-          <p:cNvSpPr>
-            <a:spLocks noGrp="1"/>
-          </p:cNvSpPr>
-          <p:nvPr>
-            <p:ph type="body" sz="quarter" idx="3"/>
-          </p:nvPr>
-        </p:nvSpPr>
-        <p:spPr>
-          <a:xfrm>
-            <a:off x="685800" y="4400550"/>
-            <a:ext cx="5486400" cy="3600450"/>
-          </a:xfrm>
-          <a:prstGeom prst="rect">
-            <a:avLst/>
-          </a:prstGeom>
-        </p:spPr>
-        <p:txBody>
-          <a:bodyPr vert="horz" lIns="91440" tIns="45720" rIns="91440" bIns="45720" rtlCol="0"/>
-          <a:lstStyle/>
-          <a:p>
-            <a:pPr lvl="0"/>
-            <a:r>
-              <a:rPr lang="en-US"/>
-              <a:t>Click to edit Master text styles</a:t>
-            </a:r>
-          </a:p>
-          <a:p>
-            <a:pPr lvl="1"/>
-            <a:r>
-              <a:rPr lang="en-US"/>
-              <a:t>Second level</a:t>
-            </a:r>
-          </a:p>
-          <a:p>
-            <a:pPr lvl="2"/>
-            <a:r>
-              <a:rPr lang="en-US"/>
-              <a:t>Third level</a:t>
-            </a:r>
-          </a:p>
-          <a:p>
-            <a:pPr lvl="3"/>
-            <a:r>
-              <a:rPr lang="en-US"/>
-              <a:t>Fourth level</a:t>
-            </a:r>
-          </a:p>
-          <a:p>
-            <a:pPr lvl="4"/>
-            <a:r>
-              <a:rPr lang="en-US"/>
-              <a:t>Fifth level</a:t>
-            </a:r>
-          </a:p>
-        </p:txBody>
-      </p:sp>
-      <p:sp>
-        <p:nvSpPr>
-          <p:cNvPr id="6" name="Footer Placeholder 5"/>
-          <p:cNvSpPr>
-            <a:spLocks noGrp="1"/>
-          </p:cNvSpPr>
-          <p:nvPr>
-            <p:ph type="ftr" sz="quarter" idx="4"/>
-          </p:nvPr>
-        </p:nvSpPr>
-        <p:spPr>
-          <a:xfrm>
-            <a:off x="0" y="8685213"/>
-            <a:ext cx="2971800" cy="458787"/>
-          </a:xfrm>
-          <a:prstGeom prst="rect">
-            <a:avLst/>
-          </a:prstGeom>
-        </p:spPr>
-        <p:txBody>
-          <a:bodyPr vert="horz" lIns="91440" tIns="45720" rIns="91440" bIns="45720" rtlCol="0" anchor="b"/>
-          <a:lstStyle>
-            <a:lvl1pPr algn="l">
-              <a:defRPr sz="1200"/>
-            </a:lvl1pPr>
-          </a:lstStyle>
-          <a:p>
-            <a:endParaRPr lang="en-US"/>
-          </a:p>
-        </p:txBody>
-      </p:sp>
-      <p:sp>
-        <p:nvSpPr>
-          <p:cNvPr id="7" name="Slide Number Placeholder 6"/>
-          <p:cNvSpPr>
-            <a:spLocks noGrp="1"/>
-          </p:cNvSpPr>
-          <p:nvPr>
-            <p:ph type="sldNum" sz="quarter" idx="5"/>
-          </p:nvPr>
-        </p:nvSpPr>
-        <p:spPr>
-          <a:xfrm>
-            <a:off x="3884613" y="8685213"/>
-            <a:ext cx="2971800" cy="458787"/>
-          </a:xfrm>
-          <a:prstGeom prst="rect">
-            <a:avLst/>
-          </a:prstGeom>
-        </p:spPr>
-        <p:txBody>
-          <a:bodyPr vert="horz" lIns="91440" tIns="45720" rIns="91440" bIns="45720" rtlCol="0" anchor="b"/>
-          <a:lstStyle>
-            <a:lvl1pPr algn="r">
-              <a:defRPr sz="1200"/>
-            </a:lvl1pPr>
-          </a:lstStyle>
-          <a:p>
-            <a:fld id="{CE5E9CC1-C706-0F49-92D6-E571CC5EEA8F}" type="slidenum">
-              <a:rPr lang="en-US"/>
-              <a:t>‹#›</a:t>
-            </a:fld>
-            <a:endParaRPr lang="en-US"/>
-          </a:p>
-        </p:txBody>
-      </p:sp>
     </p:spTree>
     <p:extLst>
       <p:ext uri="{BB962C8B-B14F-4D97-AF65-F5344CB8AC3E}">
-        <p14:creationId xmlns:p14="http://schemas.microsoft.com/office/powerpoint/2010/main" val="1024086991"/>
+        <p14:creationId xmlns:p14="http://schemas.microsoft.com/office/powerpoint/2010/main" val="4111526537"/>
       </p:ext>
     </p:extLst>
   </p:cSld>
@@ -506,10 +287,6 @@
           <a:bodyPr/>
           <a:lstStyle/>
           <a:p>
-            <a:r>
-              <a:rPr lang="en-US" dirty="0"/>
-              <a:t/>
-            </a:r>
             <a:endParaRPr lang="en-US" dirty="0"/>
           </a:p>
         </p:txBody>
@@ -594,10 +371,6 @@
           <a:bodyPr/>
           <a:lstStyle/>
           <a:p>
-            <a:r>
-              <a:rPr lang="en-US" dirty="0"/>
-              <a:t/>
-            </a:r>
             <a:endParaRPr lang="en-US" dirty="0"/>
           </a:p>
         </p:txBody>
@@ -682,10 +455,6 @@
           <a:bodyPr/>
           <a:lstStyle/>
           <a:p>
-            <a:r>
-              <a:rPr lang="en-US" dirty="0"/>
-              <a:t/>
-            </a:r>
             <a:endParaRPr lang="en-US" dirty="0"/>
           </a:p>
         </p:txBody>
@@ -770,10 +539,6 @@
           <a:bodyPr/>
           <a:lstStyle/>
           <a:p>
-            <a:r>
-              <a:rPr lang="en-US" dirty="0"/>
-              <a:t/>
-            </a:r>
             <a:endParaRPr lang="en-US" dirty="0"/>
           </a:p>
         </p:txBody>
@@ -858,10 +623,6 @@
           <a:bodyPr/>
           <a:lstStyle/>
           <a:p>
-            <a:r>
-              <a:rPr lang="en-US" dirty="0"/>
-              <a:t/>
-            </a:r>
             <a:endParaRPr lang="en-US" dirty="0"/>
           </a:p>
         </p:txBody>
@@ -946,10 +707,6 @@
           <a:bodyPr/>
           <a:lstStyle/>
           <a:p>
-            <a:r>
-              <a:rPr lang="en-US" dirty="0"/>
-              <a:t/>
-            </a:r>
             <a:endParaRPr lang="en-US" dirty="0"/>
           </a:p>
         </p:txBody>
@@ -1034,10 +791,6 @@
           <a:bodyPr/>
           <a:lstStyle/>
           <a:p>
-            <a:r>
-              <a:rPr lang="en-US" dirty="0"/>
-              <a:t/>
-            </a:r>
             <a:endParaRPr lang="en-US" dirty="0"/>
           </a:p>
         </p:txBody>
@@ -1111,6 +864,11 @@
 <file path=ppt/slideMasters/slideMaster1.xml><?xml version="1.0" encoding="utf-8"?>
 <p:sldMaster xmlns:a="http://schemas.openxmlformats.org/drawingml/2006/main" xmlns:r="http://schemas.openxmlformats.org/officeDocument/2006/relationships" xmlns:p="http://schemas.openxmlformats.org/presentationml/2006/main">
   <p:cSld>
+    <p:bg>
+      <p:bgRef idx="1001">
+        <a:schemeClr val="bg1"/>
+      </p:bgRef>
+    </p:bg>
     <p:spTree>
       <p:nvGrpSpPr>
         <p:cNvPr id="1" name=""/>
@@ -1393,6 +1151,7 @@
         <a:solidFill>
           <a:srgbClr val="FFFFFF"/>
         </a:solidFill>
+        <a:effectLst/>
       </p:bgPr>
     </p:bg>
     <p:spTree>
@@ -1431,6 +1190,13 @@
             <a:prstDash val="solid"/>
           </a:ln>
         </p:spPr>
+        <p:txBody>
+          <a:bodyPr/>
+          <a:lstStyle/>
+          <a:p>
+            <a:endParaRPr lang="en-US"/>
+          </a:p>
+        </p:txBody>
       </p:sp>
       <p:sp>
         <p:nvSpPr>
@@ -1451,6 +1217,13 @@
           </a:solidFill>
           <a:ln/>
         </p:spPr>
+        <p:txBody>
+          <a:bodyPr/>
+          <a:lstStyle/>
+          <a:p>
+            <a:endParaRPr lang="en-US"/>
+          </a:p>
+        </p:txBody>
       </p:sp>
       <p:sp>
         <p:nvSpPr>
@@ -1473,6 +1246,13 @@
           </a:solidFill>
           <a:ln/>
         </p:spPr>
+        <p:txBody>
+          <a:bodyPr/>
+          <a:lstStyle/>
+          <a:p>
+            <a:endParaRPr lang="en-US"/>
+          </a:p>
+        </p:txBody>
       </p:sp>
       <p:sp>
         <p:nvSpPr>
@@ -1495,6 +1275,13 @@
           </a:solidFill>
           <a:ln/>
         </p:spPr>
+        <p:txBody>
+          <a:bodyPr/>
+          <a:lstStyle/>
+          <a:p>
+            <a:endParaRPr lang="en-US"/>
+          </a:p>
+        </p:txBody>
       </p:sp>
       <p:sp>
         <p:nvSpPr>
@@ -1517,6 +1304,13 @@
           </a:solidFill>
           <a:ln/>
         </p:spPr>
+        <p:txBody>
+          <a:bodyPr/>
+          <a:lstStyle/>
+          <a:p>
+            <a:endParaRPr lang="en-US"/>
+          </a:p>
+        </p:txBody>
       </p:sp>
       <p:sp>
         <p:nvSpPr>
@@ -1539,6 +1333,13 @@
           </a:solidFill>
           <a:ln/>
         </p:spPr>
+        <p:txBody>
+          <a:bodyPr/>
+          <a:lstStyle/>
+          <a:p>
+            <a:endParaRPr lang="en-US"/>
+          </a:p>
+        </p:txBody>
       </p:sp>
       <p:sp>
         <p:nvSpPr>
@@ -1561,6 +1362,13 @@
           </a:solidFill>
           <a:ln/>
         </p:spPr>
+        <p:txBody>
+          <a:bodyPr/>
+          <a:lstStyle/>
+          <a:p>
+            <a:endParaRPr lang="en-US"/>
+          </a:p>
+        </p:txBody>
       </p:sp>
       <p:sp>
         <p:nvSpPr>
@@ -1583,6 +1391,13 @@
           </a:solidFill>
           <a:ln/>
         </p:spPr>
+        <p:txBody>
+          <a:bodyPr/>
+          <a:lstStyle/>
+          <a:p>
+            <a:endParaRPr lang="en-US"/>
+          </a:p>
+        </p:txBody>
       </p:sp>
       <p:sp>
         <p:nvSpPr>
@@ -1605,7 +1420,7 @@
           <a:bodyPr wrap="square" lIns="0" tIns="0" rIns="0" bIns="0" rtlCol="0" anchor="t"/>
           <a:lstStyle/>
           <a:p>
-            <a:pPr algn="l" indent="0" marL="0">
+            <a:pPr marL="0" indent="0" algn="l">
               <a:buNone/>
             </a:pPr>
             <a:r>
@@ -1619,9 +1434,6 @@
               </a:rPr>
               <a:t>*</a:t>
             </a:r>
-            <a:pPr algn="l" indent="0" marL="0">
-              <a:buNone/>
-            </a:pPr>
             <a:r>
               <a:rPr lang="en-US" sz="5200" dirty="0">
                 <a:solidFill>
@@ -1658,7 +1470,7 @@
           <a:bodyPr wrap="square" lIns="0" tIns="0" rIns="0" bIns="0" rtlCol="0" anchor="t"/>
           <a:lstStyle/>
           <a:p>
-            <a:pPr algn="l" indent="0" marL="0">
+            <a:pPr marL="0" indent="0" algn="l">
               <a:buNone/>
             </a:pPr>
             <a:r>
@@ -1697,7 +1509,7 @@
           <a:bodyPr wrap="square" lIns="0" tIns="0" rIns="0" bIns="0" rtlCol="0" anchor="t"/>
           <a:lstStyle/>
           <a:p>
-            <a:pPr algn="l" indent="0" marL="0">
+            <a:pPr marL="0" indent="0" algn="l">
               <a:buNone/>
             </a:pPr>
             <a:r>
@@ -1709,7 +1521,7 @@
                 <a:ea typeface="Inter" pitchFamily="34" charset="-122"/>
                 <a:cs typeface="Inter" pitchFamily="34" charset="-120"/>
               </a:rPr>
-              <a:t>I test how an AI decides between a sure thing and a gamble, and where its habits come from.</a:t>
+              <a:t>I test how an AI decides makes economic decisions and where those habits come from.</a:t>
             </a:r>
             <a:endParaRPr lang="en-US" sz="2600" dirty="0"/>
           </a:p>
@@ -1731,6 +1543,7 @@
         <a:solidFill>
           <a:srgbClr val="FFFFFF"/>
         </a:solidFill>
+        <a:effectLst/>
       </p:bgPr>
     </p:bg>
     <p:spTree>
@@ -1769,6 +1582,13 @@
             <a:prstDash val="solid"/>
           </a:ln>
         </p:spPr>
+        <p:txBody>
+          <a:bodyPr/>
+          <a:lstStyle/>
+          <a:p>
+            <a:endParaRPr lang="en-US"/>
+          </a:p>
+        </p:txBody>
       </p:sp>
       <p:sp>
         <p:nvSpPr>
@@ -1791,6 +1611,13 @@
           </a:solidFill>
           <a:ln/>
         </p:spPr>
+        <p:txBody>
+          <a:bodyPr/>
+          <a:lstStyle/>
+          <a:p>
+            <a:endParaRPr lang="en-US"/>
+          </a:p>
+        </p:txBody>
       </p:sp>
       <p:sp>
         <p:nvSpPr>
@@ -1811,6 +1638,13 @@
           </a:solidFill>
           <a:ln/>
         </p:spPr>
+        <p:txBody>
+          <a:bodyPr/>
+          <a:lstStyle/>
+          <a:p>
+            <a:endParaRPr lang="en-US"/>
+          </a:p>
+        </p:txBody>
       </p:sp>
       <p:sp>
         <p:nvSpPr>
@@ -1833,6 +1667,13 @@
           </a:solidFill>
           <a:ln/>
         </p:spPr>
+        <p:txBody>
+          <a:bodyPr/>
+          <a:lstStyle/>
+          <a:p>
+            <a:endParaRPr lang="en-US"/>
+          </a:p>
+        </p:txBody>
       </p:sp>
       <p:sp>
         <p:nvSpPr>
@@ -1855,6 +1696,13 @@
           </a:solidFill>
           <a:ln/>
         </p:spPr>
+        <p:txBody>
+          <a:bodyPr/>
+          <a:lstStyle/>
+          <a:p>
+            <a:endParaRPr lang="en-US"/>
+          </a:p>
+        </p:txBody>
       </p:sp>
       <p:sp>
         <p:nvSpPr>
@@ -1877,6 +1725,13 @@
           </a:solidFill>
           <a:ln/>
         </p:spPr>
+        <p:txBody>
+          <a:bodyPr/>
+          <a:lstStyle/>
+          <a:p>
+            <a:endParaRPr lang="en-US"/>
+          </a:p>
+        </p:txBody>
       </p:sp>
       <p:sp>
         <p:nvSpPr>
@@ -1899,6 +1754,13 @@
           </a:solidFill>
           <a:ln/>
         </p:spPr>
+        <p:txBody>
+          <a:bodyPr/>
+          <a:lstStyle/>
+          <a:p>
+            <a:endParaRPr lang="en-US"/>
+          </a:p>
+        </p:txBody>
       </p:sp>
       <p:sp>
         <p:nvSpPr>
@@ -1921,6 +1783,13 @@
           </a:solidFill>
           <a:ln/>
         </p:spPr>
+        <p:txBody>
+          <a:bodyPr/>
+          <a:lstStyle/>
+          <a:p>
+            <a:endParaRPr lang="en-US"/>
+          </a:p>
+        </p:txBody>
       </p:sp>
       <p:sp>
         <p:nvSpPr>
@@ -1943,7 +1812,7 @@
           <a:bodyPr wrap="square" lIns="0" tIns="0" rIns="0" bIns="0" rtlCol="0" anchor="t"/>
           <a:lstStyle/>
           <a:p>
-            <a:pPr algn="l" indent="0" marL="0">
+            <a:pPr marL="0" indent="0" algn="l">
               <a:buNone/>
             </a:pPr>
             <a:r>
@@ -1957,9 +1826,6 @@
               </a:rPr>
               <a:t>*</a:t>
             </a:r>
-            <a:pPr algn="l" indent="0" marL="0">
-              <a:buNone/>
-            </a:pPr>
             <a:r>
               <a:rPr lang="en-US" sz="4000" dirty="0">
                 <a:solidFill>
@@ -1996,7 +1862,7 @@
           <a:bodyPr wrap="square" lIns="0" tIns="0" rIns="0" bIns="0" rtlCol="0" anchor="t"/>
           <a:lstStyle/>
           <a:p>
-            <a:pPr algn="l" indent="0" marL="0">
+            <a:pPr marL="0" indent="0" algn="l">
               <a:buNone/>
             </a:pPr>
             <a:r>
@@ -2008,7 +1874,7 @@
                 <a:ea typeface="Inter" pitchFamily="34" charset="-122"/>
                 <a:cs typeface="Inter" pitchFamily="34" charset="-120"/>
               </a:rPr>
-              <a:t>AI systems are starting to make real decisions that involve money and risk, things like pricing, approvals, and deciding what to fund.</a:t>
+              <a:t>AI systems are starting to make decisions that involve money and risk, things like pricing, approvals, and deciding what to fund.</a:t>
             </a:r>
             <a:endParaRPr lang="en-US" sz="2700" dirty="0"/>
           </a:p>
@@ -2035,7 +1901,7 @@
           <a:bodyPr wrap="square" lIns="0" tIns="0" rIns="0" bIns="0" rtlCol="0" anchor="t"/>
           <a:lstStyle/>
           <a:p>
-            <a:pPr algn="l" indent="0" marL="0">
+            <a:pPr marL="0" indent="0" algn="l">
               <a:buNone/>
             </a:pPr>
             <a:r>
@@ -2047,7 +1913,7 @@
                 <a:ea typeface="Inter" pitchFamily="34" charset="-122"/>
                 <a:cs typeface="Inter" pitchFamily="34" charset="-120"/>
               </a:rPr>
-              <a:t>So it matters whether they decide sensibly, and whether we can predict and trust how they choose.</a:t>
+              <a:t>There’s an assumption that models will decide rationally, but I wanted to use behavioral economics to test if that is true. </a:t>
             </a:r>
             <a:endParaRPr lang="en-US" sz="2300" dirty="0"/>
           </a:p>
@@ -2074,11 +1940,11 @@
           <a:bodyPr wrap="square" lIns="0" tIns="0" rIns="0" bIns="0" rtlCol="0" anchor="t"/>
           <a:lstStyle/>
           <a:p>
-            <a:pPr algn="l" indent="0" marL="0">
+            <a:pPr marL="0" indent="0" algn="l">
               <a:buNone/>
             </a:pPr>
             <a:r>
-              <a:rPr lang="en-US" sz="1300" b="1" spc="200" kern="0" dirty="0">
+              <a:rPr lang="en-US" sz="1300" b="1" kern="0" spc="200" dirty="0">
                 <a:solidFill>
                   <a:srgbClr val="758C58"/>
                 </a:solidFill>
@@ -2113,7 +1979,7 @@
           <a:bodyPr wrap="square" lIns="0" tIns="0" rIns="0" bIns="0" rtlCol="0" anchor="t"/>
           <a:lstStyle/>
           <a:p>
-            <a:pPr algn="l" indent="0" marL="0">
+            <a:pPr marL="0" indent="0" algn="l">
               <a:buNone/>
             </a:pPr>
             <a:r>
@@ -2125,7 +1991,7 @@
                 <a:ea typeface="Inter" pitchFamily="34" charset="-122"/>
                 <a:cs typeface="Inter" pitchFamily="34" charset="-120"/>
               </a:rPr>
-              <a:t>When an AI picks between a sure amount and a gamble, what is it really doing, and where did that behavior come from?</a:t>
+              <a:t>When an AI picks between a sure amount and a gamble, what are its preference primitives, and if there are behavioral deviations from strict rationality, where in the training process did those come from?</a:t>
             </a:r>
             <a:endParaRPr lang="en-US" sz="2400" dirty="0"/>
           </a:p>
@@ -2147,6 +2013,7 @@
         <a:solidFill>
           <a:srgbClr val="FFFFFF"/>
         </a:solidFill>
+        <a:effectLst/>
       </p:bgPr>
     </p:bg>
     <p:spTree>
@@ -2185,6 +2052,13 @@
             <a:prstDash val="solid"/>
           </a:ln>
         </p:spPr>
+        <p:txBody>
+          <a:bodyPr/>
+          <a:lstStyle/>
+          <a:p>
+            <a:endParaRPr lang="en-US"/>
+          </a:p>
+        </p:txBody>
       </p:sp>
       <p:sp>
         <p:nvSpPr>
@@ -2207,6 +2081,13 @@
           </a:solidFill>
           <a:ln/>
         </p:spPr>
+        <p:txBody>
+          <a:bodyPr/>
+          <a:lstStyle/>
+          <a:p>
+            <a:endParaRPr lang="en-US"/>
+          </a:p>
+        </p:txBody>
       </p:sp>
       <p:sp>
         <p:nvSpPr>
@@ -2229,6 +2110,13 @@
           </a:solidFill>
           <a:ln/>
         </p:spPr>
+        <p:txBody>
+          <a:bodyPr/>
+          <a:lstStyle/>
+          <a:p>
+            <a:endParaRPr lang="en-US"/>
+          </a:p>
+        </p:txBody>
       </p:sp>
       <p:sp>
         <p:nvSpPr>
@@ -2249,6 +2137,13 @@
           </a:solidFill>
           <a:ln/>
         </p:spPr>
+        <p:txBody>
+          <a:bodyPr/>
+          <a:lstStyle/>
+          <a:p>
+            <a:endParaRPr lang="en-US"/>
+          </a:p>
+        </p:txBody>
       </p:sp>
       <p:sp>
         <p:nvSpPr>
@@ -2271,6 +2166,13 @@
           </a:solidFill>
           <a:ln/>
         </p:spPr>
+        <p:txBody>
+          <a:bodyPr/>
+          <a:lstStyle/>
+          <a:p>
+            <a:endParaRPr lang="en-US"/>
+          </a:p>
+        </p:txBody>
       </p:sp>
       <p:sp>
         <p:nvSpPr>
@@ -2293,6 +2195,13 @@
           </a:solidFill>
           <a:ln/>
         </p:spPr>
+        <p:txBody>
+          <a:bodyPr/>
+          <a:lstStyle/>
+          <a:p>
+            <a:endParaRPr lang="en-US"/>
+          </a:p>
+        </p:txBody>
       </p:sp>
       <p:sp>
         <p:nvSpPr>
@@ -2315,6 +2224,13 @@
           </a:solidFill>
           <a:ln/>
         </p:spPr>
+        <p:txBody>
+          <a:bodyPr/>
+          <a:lstStyle/>
+          <a:p>
+            <a:endParaRPr lang="en-US"/>
+          </a:p>
+        </p:txBody>
       </p:sp>
       <p:sp>
         <p:nvSpPr>
@@ -2337,6 +2253,13 @@
           </a:solidFill>
           <a:ln/>
         </p:spPr>
+        <p:txBody>
+          <a:bodyPr/>
+          <a:lstStyle/>
+          <a:p>
+            <a:endParaRPr lang="en-US"/>
+          </a:p>
+        </p:txBody>
       </p:sp>
       <p:sp>
         <p:nvSpPr>
@@ -2359,7 +2282,7 @@
           <a:bodyPr wrap="square" lIns="0" tIns="0" rIns="0" bIns="0" rtlCol="0" anchor="t"/>
           <a:lstStyle/>
           <a:p>
-            <a:pPr algn="l" indent="0" marL="0">
+            <a:pPr marL="0" indent="0" algn="l">
               <a:buNone/>
             </a:pPr>
             <a:r>
@@ -2373,9 +2296,6 @@
               </a:rPr>
               <a:t>*</a:t>
             </a:r>
-            <a:pPr algn="l" indent="0" marL="0">
-              <a:buNone/>
-            </a:pPr>
             <a:r>
               <a:rPr lang="en-US" sz="4000" dirty="0">
                 <a:solidFill>
@@ -2412,7 +2332,7 @@
           <a:bodyPr wrap="square" lIns="0" tIns="0" rIns="0" bIns="0" rtlCol="0" anchor="t"/>
           <a:lstStyle/>
           <a:p>
-            <a:pPr algn="l" indent="0" marL="0">
+            <a:pPr marL="0" indent="0" algn="l">
               <a:buNone/>
             </a:pPr>
             <a:r>
@@ -2457,7 +2377,7 @@
           <a:bodyPr wrap="square" lIns="152400" tIns="152400" rIns="152400" bIns="152400" rtlCol="0" anchor="ctr"/>
           <a:lstStyle/>
           <a:p>
-            <a:pPr algn="l" indent="0" marL="0">
+            <a:pPr marL="0" indent="0" algn="l">
               <a:lnSpc>
                 <a:spcPct val="130000"/>
               </a:lnSpc>
@@ -2477,7 +2397,7 @@
             <a:endParaRPr lang="en-US" sz="2000" dirty="0"/>
           </a:p>
           <a:p>
-            <a:pPr algn="l" indent="0" marL="0">
+            <a:pPr marL="0" indent="0" algn="l">
               <a:lnSpc>
                 <a:spcPct val="130000"/>
               </a:lnSpc>
@@ -2519,7 +2439,7 @@
           <a:bodyPr wrap="square" lIns="0" tIns="0" rIns="0" bIns="0" rtlCol="0" anchor="t"/>
           <a:lstStyle/>
           <a:p>
-            <a:pPr algn="l" indent="0" marL="0">
+            <a:pPr marL="0" indent="0" algn="l">
               <a:buNone/>
             </a:pPr>
             <a:r>
@@ -2553,6 +2473,7 @@
         <a:solidFill>
           <a:srgbClr val="FFFFFF"/>
         </a:solidFill>
+        <a:effectLst/>
       </p:bgPr>
     </p:bg>
     <p:spTree>
@@ -2591,6 +2512,13 @@
             <a:prstDash val="solid"/>
           </a:ln>
         </p:spPr>
+        <p:txBody>
+          <a:bodyPr/>
+          <a:lstStyle/>
+          <a:p>
+            <a:endParaRPr lang="en-US"/>
+          </a:p>
+        </p:txBody>
       </p:sp>
       <p:sp>
         <p:nvSpPr>
@@ -2613,6 +2541,13 @@
           </a:solidFill>
           <a:ln/>
         </p:spPr>
+        <p:txBody>
+          <a:bodyPr/>
+          <a:lstStyle/>
+          <a:p>
+            <a:endParaRPr lang="en-US"/>
+          </a:p>
+        </p:txBody>
       </p:sp>
       <p:sp>
         <p:nvSpPr>
@@ -2635,6 +2570,13 @@
           </a:solidFill>
           <a:ln/>
         </p:spPr>
+        <p:txBody>
+          <a:bodyPr/>
+          <a:lstStyle/>
+          <a:p>
+            <a:endParaRPr lang="en-US"/>
+          </a:p>
+        </p:txBody>
       </p:sp>
       <p:sp>
         <p:nvSpPr>
@@ -2657,6 +2599,13 @@
           </a:solidFill>
           <a:ln/>
         </p:spPr>
+        <p:txBody>
+          <a:bodyPr/>
+          <a:lstStyle/>
+          <a:p>
+            <a:endParaRPr lang="en-US"/>
+          </a:p>
+        </p:txBody>
       </p:sp>
       <p:sp>
         <p:nvSpPr>
@@ -2677,6 +2626,13 @@
           </a:solidFill>
           <a:ln/>
         </p:spPr>
+        <p:txBody>
+          <a:bodyPr/>
+          <a:lstStyle/>
+          <a:p>
+            <a:endParaRPr lang="en-US"/>
+          </a:p>
+        </p:txBody>
       </p:sp>
       <p:sp>
         <p:nvSpPr>
@@ -2699,6 +2655,13 @@
           </a:solidFill>
           <a:ln/>
         </p:spPr>
+        <p:txBody>
+          <a:bodyPr/>
+          <a:lstStyle/>
+          <a:p>
+            <a:endParaRPr lang="en-US"/>
+          </a:p>
+        </p:txBody>
       </p:sp>
       <p:sp>
         <p:nvSpPr>
@@ -2721,6 +2684,13 @@
           </a:solidFill>
           <a:ln/>
         </p:spPr>
+        <p:txBody>
+          <a:bodyPr/>
+          <a:lstStyle/>
+          <a:p>
+            <a:endParaRPr lang="en-US"/>
+          </a:p>
+        </p:txBody>
       </p:sp>
       <p:sp>
         <p:nvSpPr>
@@ -2743,6 +2713,13 @@
           </a:solidFill>
           <a:ln/>
         </p:spPr>
+        <p:txBody>
+          <a:bodyPr/>
+          <a:lstStyle/>
+          <a:p>
+            <a:endParaRPr lang="en-US"/>
+          </a:p>
+        </p:txBody>
       </p:sp>
       <p:sp>
         <p:nvSpPr>
@@ -2765,7 +2742,7 @@
           <a:bodyPr wrap="square" lIns="0" tIns="0" rIns="0" bIns="0" rtlCol="0" anchor="t"/>
           <a:lstStyle/>
           <a:p>
-            <a:pPr algn="l" indent="0" marL="0">
+            <a:pPr marL="0" indent="0" algn="l">
               <a:buNone/>
             </a:pPr>
             <a:r>
@@ -2779,9 +2756,6 @@
               </a:rPr>
               <a:t>*</a:t>
             </a:r>
-            <a:pPr algn="l" indent="0" marL="0">
-              <a:buNone/>
-            </a:pPr>
             <a:r>
               <a:rPr lang="en-US" sz="3400" dirty="0">
                 <a:solidFill>
@@ -2818,7 +2792,7 @@
           <a:bodyPr wrap="square" lIns="0" tIns="0" rIns="0" bIns="0" rtlCol="0" anchor="t"/>
           <a:lstStyle/>
           <a:p>
-            <a:pPr algn="l" indent="0" marL="0">
+            <a:pPr marL="0" indent="0" algn="l">
               <a:buNone/>
             </a:pPr>
             <a:r>
@@ -2857,11 +2831,11 @@
           <a:bodyPr wrap="square" lIns="0" tIns="0" rIns="0" bIns="0" rtlCol="0" anchor="t"/>
           <a:lstStyle/>
           <a:p>
-            <a:pPr algn="l" indent="0" marL="0">
+            <a:pPr marL="0" indent="0" algn="l">
               <a:buNone/>
             </a:pPr>
             <a:r>
-              <a:rPr lang="en-US" sz="1300" b="1" spc="200" kern="0" dirty="0">
+              <a:rPr lang="en-US" sz="1300" b="1" kern="0" spc="200" dirty="0">
                 <a:solidFill>
                   <a:srgbClr val="758C58"/>
                 </a:solidFill>
@@ -2896,7 +2870,7 @@
           <a:bodyPr wrap="square" lIns="0" tIns="0" rIns="0" bIns="0" rtlCol="0" anchor="t"/>
           <a:lstStyle/>
           <a:p>
-            <a:pPr algn="l" indent="0" marL="0">
+            <a:pPr marL="0" indent="0" algn="l">
               <a:buNone/>
             </a:pPr>
             <a:r>
@@ -2908,7 +2882,7 @@
                 <a:ea typeface="Inter" pitchFamily="34" charset="-122"/>
                 <a:cs typeface="Inter" pitchFamily="34" charset="-120"/>
               </a:rPr>
-              <a:t>It chases likely wins and turns down long shots no matter how big the prize. It reads dollar amounts fine when there is no gamble, so this is a specific blind spot, not bad math.</a:t>
+              <a:t>It chases likely wins and turns down long shots no matter how big the prize. It reads dollar amounts fine when there is no gamble.</a:t>
             </a:r>
             <a:endParaRPr lang="en-US" sz="1900" dirty="0"/>
           </a:p>
@@ -2916,14 +2890,14 @@
       </p:sp>
       <p:pic>
         <p:nvPicPr>
-          <p:cNvPr id="14" name="Image 0" descr="/Users/johnpb89/Code/llm-revealed-preferences/writeups/figures/fig3_empirical_p1.png">    </p:cNvPr>
+          <p:cNvPr id="14" name="Image 0" descr="/Users/johnpb89/Code/llm-revealed-preferences/writeups/figures/fig3_empirical_p1.png"/>
           <p:cNvPicPr>
             <a:picLocks noChangeAspect="1"/>
           </p:cNvPicPr>
           <p:nvPr/>
         </p:nvPicPr>
         <p:blipFill>
-          <a:blip r:embed="rId1"/>
+          <a:blip r:embed="rId3"/>
           <a:stretch>
             <a:fillRect/>
           </a:stretch>
@@ -2954,6 +2928,7 @@
         <a:solidFill>
           <a:srgbClr val="FFFFFF"/>
         </a:solidFill>
+        <a:effectLst/>
       </p:bgPr>
     </p:bg>
     <p:spTree>
@@ -2992,6 +2967,13 @@
             <a:prstDash val="solid"/>
           </a:ln>
         </p:spPr>
+        <p:txBody>
+          <a:bodyPr/>
+          <a:lstStyle/>
+          <a:p>
+            <a:endParaRPr lang="en-US"/>
+          </a:p>
+        </p:txBody>
       </p:sp>
       <p:sp>
         <p:nvSpPr>
@@ -3014,6 +2996,13 @@
           </a:solidFill>
           <a:ln/>
         </p:spPr>
+        <p:txBody>
+          <a:bodyPr/>
+          <a:lstStyle/>
+          <a:p>
+            <a:endParaRPr lang="en-US"/>
+          </a:p>
+        </p:txBody>
       </p:sp>
       <p:sp>
         <p:nvSpPr>
@@ -3036,6 +3025,13 @@
           </a:solidFill>
           <a:ln/>
         </p:spPr>
+        <p:txBody>
+          <a:bodyPr/>
+          <a:lstStyle/>
+          <a:p>
+            <a:endParaRPr lang="en-US"/>
+          </a:p>
+        </p:txBody>
       </p:sp>
       <p:sp>
         <p:nvSpPr>
@@ -3058,6 +3054,13 @@
           </a:solidFill>
           <a:ln/>
         </p:spPr>
+        <p:txBody>
+          <a:bodyPr/>
+          <a:lstStyle/>
+          <a:p>
+            <a:endParaRPr lang="en-US"/>
+          </a:p>
+        </p:txBody>
       </p:sp>
       <p:sp>
         <p:nvSpPr>
@@ -3080,6 +3083,13 @@
           </a:solidFill>
           <a:ln/>
         </p:spPr>
+        <p:txBody>
+          <a:bodyPr/>
+          <a:lstStyle/>
+          <a:p>
+            <a:endParaRPr lang="en-US"/>
+          </a:p>
+        </p:txBody>
       </p:sp>
       <p:sp>
         <p:nvSpPr>
@@ -3100,6 +3110,13 @@
           </a:solidFill>
           <a:ln/>
         </p:spPr>
+        <p:txBody>
+          <a:bodyPr/>
+          <a:lstStyle/>
+          <a:p>
+            <a:endParaRPr lang="en-US"/>
+          </a:p>
+        </p:txBody>
       </p:sp>
       <p:sp>
         <p:nvSpPr>
@@ -3122,6 +3139,13 @@
           </a:solidFill>
           <a:ln/>
         </p:spPr>
+        <p:txBody>
+          <a:bodyPr/>
+          <a:lstStyle/>
+          <a:p>
+            <a:endParaRPr lang="en-US"/>
+          </a:p>
+        </p:txBody>
       </p:sp>
       <p:sp>
         <p:nvSpPr>
@@ -3144,6 +3168,13 @@
           </a:solidFill>
           <a:ln/>
         </p:spPr>
+        <p:txBody>
+          <a:bodyPr/>
+          <a:lstStyle/>
+          <a:p>
+            <a:endParaRPr lang="en-US"/>
+          </a:p>
+        </p:txBody>
       </p:sp>
       <p:sp>
         <p:nvSpPr>
@@ -3166,7 +3197,7 @@
           <a:bodyPr wrap="square" lIns="0" tIns="0" rIns="0" bIns="0" rtlCol="0" anchor="t"/>
           <a:lstStyle/>
           <a:p>
-            <a:pPr algn="l" indent="0" marL="0">
+            <a:pPr marL="0" indent="0" algn="l">
               <a:buNone/>
             </a:pPr>
             <a:r>
@@ -3180,9 +3211,6 @@
               </a:rPr>
               <a:t>*</a:t>
             </a:r>
-            <a:pPr algn="l" indent="0" marL="0">
-              <a:buNone/>
-            </a:pPr>
             <a:r>
               <a:rPr lang="en-US" sz="3400" dirty="0">
                 <a:solidFill>
@@ -3219,7 +3247,7 @@
           <a:bodyPr wrap="square" lIns="0" tIns="0" rIns="0" bIns="0" rtlCol="0" anchor="t"/>
           <a:lstStyle/>
           <a:p>
-            <a:pPr algn="l" indent="0" marL="0">
+            <a:pPr marL="0" indent="0" algn="l">
               <a:buNone/>
             </a:pPr>
             <a:r>
@@ -3258,11 +3286,11 @@
           <a:bodyPr wrap="square" lIns="0" tIns="0" rIns="0" bIns="0" rtlCol="0" anchor="t"/>
           <a:lstStyle/>
           <a:p>
-            <a:pPr algn="l" indent="0" marL="0">
+            <a:pPr marL="0" indent="0" algn="l">
               <a:buNone/>
             </a:pPr>
             <a:r>
-              <a:rPr lang="en-US" sz="1300" b="1" spc="200" kern="0" dirty="0">
+              <a:rPr lang="en-US" sz="1300" b="1" kern="0" spc="200" dirty="0">
                 <a:solidFill>
                   <a:srgbClr val="758C58"/>
                 </a:solidFill>
@@ -3297,7 +3325,7 @@
           <a:bodyPr wrap="square" lIns="0" tIns="0" rIns="0" bIns="0" rtlCol="0" anchor="t"/>
           <a:lstStyle/>
           <a:p>
-            <a:pPr algn="l" indent="0" marL="0">
+            <a:pPr marL="0" indent="0" algn="l">
               <a:buNone/>
             </a:pPr>
             <a:r>
@@ -3317,14 +3345,14 @@
       </p:sp>
       <p:pic>
         <p:nvPicPr>
-          <p:cNvPr id="14" name="Image 0" descr="/Users/johnpb89/Code/llm-revealed-preferences/writeups/figures/fig5_framing.png">    </p:cNvPr>
+          <p:cNvPr id="14" name="Image 0" descr="/Users/johnpb89/Code/llm-revealed-preferences/writeups/figures/fig5_framing.png"/>
           <p:cNvPicPr>
             <a:picLocks noChangeAspect="1"/>
           </p:cNvPicPr>
           <p:nvPr/>
         </p:nvPicPr>
         <p:blipFill>
-          <a:blip r:embed="rId1"/>
+          <a:blip r:embed="rId3"/>
           <a:stretch>
             <a:fillRect/>
           </a:stretch>
@@ -3355,6 +3383,7 @@
         <a:solidFill>
           <a:srgbClr val="FFFFFF"/>
         </a:solidFill>
+        <a:effectLst/>
       </p:bgPr>
     </p:bg>
     <p:spTree>
@@ -3393,6 +3422,13 @@
             <a:prstDash val="solid"/>
           </a:ln>
         </p:spPr>
+        <p:txBody>
+          <a:bodyPr/>
+          <a:lstStyle/>
+          <a:p>
+            <a:endParaRPr lang="en-US"/>
+          </a:p>
+        </p:txBody>
       </p:sp>
       <p:sp>
         <p:nvSpPr>
@@ -3415,6 +3451,13 @@
           </a:solidFill>
           <a:ln/>
         </p:spPr>
+        <p:txBody>
+          <a:bodyPr/>
+          <a:lstStyle/>
+          <a:p>
+            <a:endParaRPr lang="en-US"/>
+          </a:p>
+        </p:txBody>
       </p:sp>
       <p:sp>
         <p:nvSpPr>
@@ -3437,6 +3480,13 @@
           </a:solidFill>
           <a:ln/>
         </p:spPr>
+        <p:txBody>
+          <a:bodyPr/>
+          <a:lstStyle/>
+          <a:p>
+            <a:endParaRPr lang="en-US"/>
+          </a:p>
+        </p:txBody>
       </p:sp>
       <p:sp>
         <p:nvSpPr>
@@ -3459,6 +3509,13 @@
           </a:solidFill>
           <a:ln/>
         </p:spPr>
+        <p:txBody>
+          <a:bodyPr/>
+          <a:lstStyle/>
+          <a:p>
+            <a:endParaRPr lang="en-US"/>
+          </a:p>
+        </p:txBody>
       </p:sp>
       <p:sp>
         <p:nvSpPr>
@@ -3481,6 +3538,13 @@
           </a:solidFill>
           <a:ln/>
         </p:spPr>
+        <p:txBody>
+          <a:bodyPr/>
+          <a:lstStyle/>
+          <a:p>
+            <a:endParaRPr lang="en-US"/>
+          </a:p>
+        </p:txBody>
       </p:sp>
       <p:sp>
         <p:nvSpPr>
@@ -3503,6 +3567,13 @@
           </a:solidFill>
           <a:ln/>
         </p:spPr>
+        <p:txBody>
+          <a:bodyPr/>
+          <a:lstStyle/>
+          <a:p>
+            <a:endParaRPr lang="en-US"/>
+          </a:p>
+        </p:txBody>
       </p:sp>
       <p:sp>
         <p:nvSpPr>
@@ -3523,6 +3594,13 @@
           </a:solidFill>
           <a:ln/>
         </p:spPr>
+        <p:txBody>
+          <a:bodyPr/>
+          <a:lstStyle/>
+          <a:p>
+            <a:endParaRPr lang="en-US"/>
+          </a:p>
+        </p:txBody>
       </p:sp>
       <p:sp>
         <p:nvSpPr>
@@ -3545,6 +3623,13 @@
           </a:solidFill>
           <a:ln/>
         </p:spPr>
+        <p:txBody>
+          <a:bodyPr/>
+          <a:lstStyle/>
+          <a:p>
+            <a:endParaRPr lang="en-US"/>
+          </a:p>
+        </p:txBody>
       </p:sp>
       <p:sp>
         <p:nvSpPr>
@@ -3567,7 +3652,7 @@
           <a:bodyPr wrap="square" lIns="0" tIns="0" rIns="0" bIns="0" rtlCol="0" anchor="t"/>
           <a:lstStyle/>
           <a:p>
-            <a:pPr algn="l" indent="0" marL="0">
+            <a:pPr marL="0" indent="0" algn="l">
               <a:buNone/>
             </a:pPr>
             <a:r>
@@ -3581,9 +3666,6 @@
               </a:rPr>
               <a:t>*</a:t>
             </a:r>
-            <a:pPr algn="l" indent="0" marL="0">
-              <a:buNone/>
-            </a:pPr>
             <a:r>
               <a:rPr lang="en-US" sz="3400" dirty="0">
                 <a:solidFill>
@@ -3620,7 +3702,7 @@
           <a:bodyPr wrap="square" lIns="0" tIns="0" rIns="0" bIns="0" rtlCol="0" anchor="t"/>
           <a:lstStyle/>
           <a:p>
-            <a:pPr algn="l" indent="0" marL="0">
+            <a:pPr marL="0" indent="0" algn="l">
               <a:buNone/>
             </a:pPr>
             <a:r>
@@ -3659,7 +3741,7 @@
           <a:bodyPr wrap="square" lIns="0" tIns="0" rIns="0" bIns="0" rtlCol="0" anchor="t"/>
           <a:lstStyle/>
           <a:p>
-            <a:pPr algn="l" indent="0" marL="0">
+            <a:pPr marL="0" indent="0" algn="l">
               <a:buNone/>
             </a:pPr>
             <a:r>
@@ -3702,7 +3784,7 @@
           <a:bodyPr wrap="square" lIns="50800" tIns="50800" rIns="50800" bIns="50800" rtlCol="0" anchor="ctr"/>
           <a:lstStyle/>
           <a:p>
-            <a:pPr algn="ctr" indent="0" marL="0">
+            <a:pPr marL="0" indent="0" algn="ctr">
               <a:buNone/>
             </a:pPr>
             <a:r>
@@ -3719,7 +3801,7 @@
             <a:endParaRPr lang="en-US" sz="1700" dirty="0"/>
           </a:p>
           <a:p>
-            <a:pPr algn="ctr" indent="0" marL="0">
+            <a:pPr marL="0" indent="0" algn="ctr">
               <a:buNone/>
             </a:pPr>
             <a:r>
@@ -3760,6 +3842,13 @@
             <a:tailEnd type="triangle"/>
           </a:ln>
         </p:spPr>
+        <p:txBody>
+          <a:bodyPr/>
+          <a:lstStyle/>
+          <a:p>
+            <a:endParaRPr lang="en-US"/>
+          </a:p>
+        </p:txBody>
       </p:sp>
       <p:sp>
         <p:nvSpPr>
@@ -3786,7 +3875,7 @@
           <a:bodyPr wrap="square" lIns="50800" tIns="50800" rIns="50800" bIns="50800" rtlCol="0" anchor="ctr"/>
           <a:lstStyle/>
           <a:p>
-            <a:pPr algn="ctr" indent="0" marL="0">
+            <a:pPr marL="0" indent="0" algn="ctr">
               <a:buNone/>
             </a:pPr>
             <a:r>
@@ -3803,7 +3892,7 @@
             <a:endParaRPr lang="en-US" sz="1700" dirty="0"/>
           </a:p>
           <a:p>
-            <a:pPr algn="ctr" indent="0" marL="0">
+            <a:pPr marL="0" indent="0" algn="ctr">
               <a:buNone/>
             </a:pPr>
             <a:r>
@@ -3842,7 +3931,7 @@
           <a:bodyPr wrap="square" lIns="0" tIns="0" rIns="0" bIns="0" rtlCol="0" anchor="t"/>
           <a:lstStyle/>
           <a:p>
-            <a:pPr algn="l" indent="0" marL="0">
+            <a:pPr marL="0" indent="0" algn="l">
               <a:buNone/>
             </a:pPr>
             <a:r>
@@ -3881,11 +3970,11 @@
           <a:bodyPr wrap="square" lIns="0" tIns="0" rIns="0" bIns="0" rtlCol="0" anchor="t"/>
           <a:lstStyle/>
           <a:p>
-            <a:pPr algn="l" indent="0" marL="0">
+            <a:pPr marL="0" indent="0" algn="l">
               <a:buNone/>
             </a:pPr>
             <a:r>
-              <a:rPr lang="en-US" sz="1300" b="1" spc="200" kern="0" dirty="0">
+              <a:rPr lang="en-US" sz="1300" b="1" kern="0" spc="200" dirty="0">
                 <a:solidFill>
                   <a:srgbClr val="758C58"/>
                 </a:solidFill>
@@ -3920,7 +4009,7 @@
           <a:bodyPr wrap="square" lIns="0" tIns="0" rIns="0" bIns="0" rtlCol="0" anchor="t"/>
           <a:lstStyle/>
           <a:p>
-            <a:pPr algn="l" indent="0" marL="0">
+            <a:pPr marL="0" indent="0" algn="l">
               <a:buNone/>
             </a:pPr>
             <a:r>
@@ -3954,6 +4043,7 @@
         <a:solidFill>
           <a:srgbClr val="FFFFFF"/>
         </a:solidFill>
+        <a:effectLst/>
       </p:bgPr>
     </p:bg>
     <p:spTree>
@@ -3992,6 +4082,13 @@
             <a:prstDash val="solid"/>
           </a:ln>
         </p:spPr>
+        <p:txBody>
+          <a:bodyPr/>
+          <a:lstStyle/>
+          <a:p>
+            <a:endParaRPr lang="en-US"/>
+          </a:p>
+        </p:txBody>
       </p:sp>
       <p:sp>
         <p:nvSpPr>
@@ -4014,6 +4111,13 @@
           </a:solidFill>
           <a:ln/>
         </p:spPr>
+        <p:txBody>
+          <a:bodyPr/>
+          <a:lstStyle/>
+          <a:p>
+            <a:endParaRPr lang="en-US"/>
+          </a:p>
+        </p:txBody>
       </p:sp>
       <p:sp>
         <p:nvSpPr>
@@ -4036,6 +4140,13 @@
           </a:solidFill>
           <a:ln/>
         </p:spPr>
+        <p:txBody>
+          <a:bodyPr/>
+          <a:lstStyle/>
+          <a:p>
+            <a:endParaRPr lang="en-US"/>
+          </a:p>
+        </p:txBody>
       </p:sp>
       <p:sp>
         <p:nvSpPr>
@@ -4058,6 +4169,13 @@
           </a:solidFill>
           <a:ln/>
         </p:spPr>
+        <p:txBody>
+          <a:bodyPr/>
+          <a:lstStyle/>
+          <a:p>
+            <a:endParaRPr lang="en-US"/>
+          </a:p>
+        </p:txBody>
       </p:sp>
       <p:sp>
         <p:nvSpPr>
@@ -4080,6 +4198,13 @@
           </a:solidFill>
           <a:ln/>
         </p:spPr>
+        <p:txBody>
+          <a:bodyPr/>
+          <a:lstStyle/>
+          <a:p>
+            <a:endParaRPr lang="en-US"/>
+          </a:p>
+        </p:txBody>
       </p:sp>
       <p:sp>
         <p:nvSpPr>
@@ -4102,6 +4227,13 @@
           </a:solidFill>
           <a:ln/>
         </p:spPr>
+        <p:txBody>
+          <a:bodyPr/>
+          <a:lstStyle/>
+          <a:p>
+            <a:endParaRPr lang="en-US"/>
+          </a:p>
+        </p:txBody>
       </p:sp>
       <p:sp>
         <p:nvSpPr>
@@ -4124,6 +4256,13 @@
           </a:solidFill>
           <a:ln/>
         </p:spPr>
+        <p:txBody>
+          <a:bodyPr/>
+          <a:lstStyle/>
+          <a:p>
+            <a:endParaRPr lang="en-US"/>
+          </a:p>
+        </p:txBody>
       </p:sp>
       <p:sp>
         <p:nvSpPr>
@@ -4144,6 +4283,13 @@
           </a:solidFill>
           <a:ln/>
         </p:spPr>
+        <p:txBody>
+          <a:bodyPr/>
+          <a:lstStyle/>
+          <a:p>
+            <a:endParaRPr lang="en-US"/>
+          </a:p>
+        </p:txBody>
       </p:sp>
       <p:sp>
         <p:nvSpPr>
@@ -4166,7 +4312,7 @@
           <a:bodyPr wrap="square" lIns="0" tIns="0" rIns="0" bIns="0" rtlCol="0" anchor="t"/>
           <a:lstStyle/>
           <a:p>
-            <a:pPr algn="l" indent="0" marL="0">
+            <a:pPr marL="0" indent="0" algn="l">
               <a:buNone/>
             </a:pPr>
             <a:r>
@@ -4180,9 +4326,6 @@
               </a:rPr>
               <a:t>*</a:t>
             </a:r>
-            <a:pPr algn="l" indent="0" marL="0">
-              <a:buNone/>
-            </a:pPr>
             <a:r>
               <a:rPr lang="en-US" sz="3600" dirty="0">
                 <a:solidFill>
@@ -4219,11 +4362,11 @@
           <a:bodyPr wrap="square" lIns="0" tIns="0" rIns="0" bIns="0" rtlCol="0" anchor="t"/>
           <a:lstStyle/>
           <a:p>
-            <a:pPr algn="l" indent="0" marL="0">
+            <a:pPr marL="0" indent="0" algn="l">
               <a:buNone/>
             </a:pPr>
             <a:r>
-              <a:rPr lang="en-US" sz="1300" b="1" spc="200" kern="0" dirty="0">
+              <a:rPr lang="en-US" sz="1300" b="1" kern="0" spc="200" dirty="0">
                 <a:solidFill>
                   <a:srgbClr val="758C58"/>
                 </a:solidFill>
@@ -4258,7 +4401,7 @@
           <a:bodyPr wrap="square" lIns="0" tIns="0" rIns="0" bIns="0" rtlCol="0" anchor="t"/>
           <a:lstStyle/>
           <a:p>
-            <a:pPr algn="l" indent="0" marL="0">
+            <a:pPr marL="0" indent="0" algn="l">
               <a:buNone/>
             </a:pPr>
             <a:r>
@@ -4297,11 +4440,11 @@
           <a:bodyPr wrap="square" lIns="0" tIns="0" rIns="0" bIns="0" rtlCol="0" anchor="t"/>
           <a:lstStyle/>
           <a:p>
-            <a:pPr algn="l" indent="0" marL="0">
+            <a:pPr marL="0" indent="0" algn="l">
               <a:buNone/>
             </a:pPr>
             <a:r>
-              <a:rPr lang="en-US" sz="1300" b="1" spc="200" kern="0" dirty="0">
+              <a:rPr lang="en-US" sz="1300" b="1" kern="0" spc="200" dirty="0">
                 <a:solidFill>
                   <a:srgbClr val="758C58"/>
                 </a:solidFill>
@@ -4336,7 +4479,7 @@
           <a:bodyPr wrap="square" lIns="0" tIns="0" rIns="0" bIns="0" rtlCol="0" anchor="t"/>
           <a:lstStyle/>
           <a:p>
-            <a:pPr algn="l" indent="0" marL="0">
+            <a:pPr marL="0" indent="0" algn="l">
               <a:buNone/>
             </a:pPr>
             <a:r>
@@ -4375,7 +4518,7 @@
           <a:bodyPr wrap="square" lIns="0" tIns="0" rIns="0" bIns="0" rtlCol="0" anchor="t"/>
           <a:lstStyle/>
           <a:p>
-            <a:pPr algn="l" indent="0" marL="0">
+            <a:pPr marL="0" indent="0" algn="l">
               <a:buNone/>
             </a:pPr>
             <a:r>
@@ -4694,4 +4837,319 @@
     </a:ext>
   </a:extLst>
 </a:theme>
+</file>
+
+<file path=ppt/theme/theme2.xml><?xml version="1.0" encoding="utf-8"?>
+<a:theme xmlns:a="http://schemas.openxmlformats.org/drawingml/2006/main" name="Office Theme">
+  <a:themeElements>
+    <a:clrScheme name="Office">
+      <a:dk1>
+        <a:sysClr val="windowText" lastClr="000000"/>
+      </a:dk1>
+      <a:lt1>
+        <a:sysClr val="window" lastClr="FFFFFF"/>
+      </a:lt1>
+      <a:dk2>
+        <a:srgbClr val="0E2841"/>
+      </a:dk2>
+      <a:lt2>
+        <a:srgbClr val="E8E8E8"/>
+      </a:lt2>
+      <a:accent1>
+        <a:srgbClr val="156082"/>
+      </a:accent1>
+      <a:accent2>
+        <a:srgbClr val="E97132"/>
+      </a:accent2>
+      <a:accent3>
+        <a:srgbClr val="196B24"/>
+      </a:accent3>
+      <a:accent4>
+        <a:srgbClr val="0F9ED5"/>
+      </a:accent4>
+      <a:accent5>
+        <a:srgbClr val="A02B93"/>
+      </a:accent5>
+      <a:accent6>
+        <a:srgbClr val="4EA72E"/>
+      </a:accent6>
+      <a:hlink>
+        <a:srgbClr val="467886"/>
+      </a:hlink>
+      <a:folHlink>
+        <a:srgbClr val="96607D"/>
+      </a:folHlink>
+    </a:clrScheme>
+    <a:fontScheme name="Office">
+      <a:majorFont>
+        <a:latin typeface="Aptos Display" panose="02110004020202020204"/>
+        <a:ea typeface=""/>
+        <a:cs typeface=""/>
+        <a:font script="Jpan" typeface="游ゴシック Light"/>
+        <a:font script="Hang" typeface="맑은 고딕"/>
+        <a:font script="Hans" typeface="等线 Light"/>
+        <a:font script="Hant" typeface="新細明體"/>
+        <a:font script="Arab" typeface="Times New Roman"/>
+        <a:font script="Hebr" typeface="Times New Roman"/>
+        <a:font script="Thai" typeface="Angsana New"/>
+        <a:font script="Ethi" typeface="Nyala"/>
+        <a:font script="Beng" typeface="Vrinda"/>
+        <a:font script="Gujr" typeface="Shruti"/>
+        <a:font script="Khmr" typeface="MoolBoran"/>
+        <a:font script="Knda" typeface="Tunga"/>
+        <a:font script="Guru" typeface="Raavi"/>
+        <a:font script="Cans" typeface="Euphemia"/>
+        <a:font script="Cher" typeface="Plantagenet Cherokee"/>
+        <a:font script="Yiii" typeface="Microsoft Yi Baiti"/>
+        <a:font script="Tibt" typeface="Microsoft Himalaya"/>
+        <a:font script="Thaa" typeface="MV Boli"/>
+        <a:font script="Deva" typeface="Mangal"/>
+        <a:font script="Telu" typeface="Gautami"/>
+        <a:font script="Taml" typeface="Latha"/>
+        <a:font script="Syrc" typeface="Estrangelo Edessa"/>
+        <a:font script="Orya" typeface="Kalinga"/>
+        <a:font script="Mlym" typeface="Kartika"/>
+        <a:font script="Laoo" typeface="DokChampa"/>
+        <a:font script="Sinh" typeface="Iskoola Pota"/>
+        <a:font script="Mong" typeface="Mongolian Baiti"/>
+        <a:font script="Viet" typeface="Times New Roman"/>
+        <a:font script="Uigh" typeface="Microsoft Uighur"/>
+        <a:font script="Geor" typeface="Sylfaen"/>
+        <a:font script="Armn" typeface="Arial"/>
+        <a:font script="Bugi" typeface="Leelawadee UI"/>
+        <a:font script="Bopo" typeface="Microsoft JhengHei"/>
+        <a:font script="Java" typeface="Javanese Text"/>
+        <a:font script="Lisu" typeface="Segoe UI"/>
+        <a:font script="Mymr" typeface="Myanmar Text"/>
+        <a:font script="Nkoo" typeface="Ebrima"/>
+        <a:font script="Olck" typeface="Nirmala UI"/>
+        <a:font script="Osma" typeface="Ebrima"/>
+        <a:font script="Phag" typeface="Phagspa"/>
+        <a:font script="Syrn" typeface="Estrangelo Edessa"/>
+        <a:font script="Syrj" typeface="Estrangelo Edessa"/>
+        <a:font script="Syre" typeface="Estrangelo Edessa"/>
+        <a:font script="Sora" typeface="Nirmala UI"/>
+        <a:font script="Tale" typeface="Microsoft Tai Le"/>
+        <a:font script="Talu" typeface="Microsoft New Tai Lue"/>
+        <a:font script="Tfng" typeface="Ebrima"/>
+      </a:majorFont>
+      <a:minorFont>
+        <a:latin typeface="Aptos" panose="02110004020202020204"/>
+        <a:ea typeface=""/>
+        <a:cs typeface=""/>
+        <a:font script="Jpan" typeface="游ゴシック"/>
+        <a:font script="Hang" typeface="맑은 고딕"/>
+        <a:font script="Hans" typeface="等线"/>
+        <a:font script="Hant" typeface="新細明體"/>
+        <a:font script="Arab" typeface="Arial"/>
+        <a:font script="Hebr" typeface="Arial"/>
+        <a:font script="Thai" typeface="Cordia New"/>
+        <a:font script="Ethi" typeface="Nyala"/>
+        <a:font script="Beng" typeface="Vrinda"/>
+        <a:font script="Gujr" typeface="Shruti"/>
+        <a:font script="Khmr" typeface="DaunPenh"/>
+        <a:font script="Knda" typeface="Tunga"/>
+        <a:font script="Guru" typeface="Raavi"/>
+        <a:font script="Cans" typeface="Euphemia"/>
+        <a:font script="Cher" typeface="Plantagenet Cherokee"/>
+        <a:font script="Yiii" typeface="Microsoft Yi Baiti"/>
+        <a:font script="Tibt" typeface="Microsoft Himalaya"/>
+        <a:font script="Thaa" typeface="MV Boli"/>
+        <a:font script="Deva" typeface="Mangal"/>
+        <a:font script="Telu" typeface="Gautami"/>
+        <a:font script="Taml" typeface="Latha"/>
+        <a:font script="Syrc" typeface="Estrangelo Edessa"/>
+        <a:font script="Orya" typeface="Kalinga"/>
+        <a:font script="Mlym" typeface="Kartika"/>
+        <a:font script="Laoo" typeface="DokChampa"/>
+        <a:font script="Sinh" typeface="Iskoola Pota"/>
+        <a:font script="Mong" typeface="Mongolian Baiti"/>
+        <a:font script="Viet" typeface="Arial"/>
+        <a:font script="Uigh" typeface="Microsoft Uighur"/>
+        <a:font script="Geor" typeface="Sylfaen"/>
+        <a:font script="Armn" typeface="Arial"/>
+        <a:font script="Bugi" typeface="Leelawadee UI"/>
+        <a:font script="Bopo" typeface="Microsoft JhengHei"/>
+        <a:font script="Java" typeface="Javanese Text"/>
+        <a:font script="Lisu" typeface="Segoe UI"/>
+        <a:font script="Mymr" typeface="Myanmar Text"/>
+        <a:font script="Nkoo" typeface="Ebrima"/>
+        <a:font script="Olck" typeface="Nirmala UI"/>
+        <a:font script="Osma" typeface="Ebrima"/>
+        <a:font script="Phag" typeface="Phagspa"/>
+        <a:font script="Syrn" typeface="Estrangelo Edessa"/>
+        <a:font script="Syrj" typeface="Estrangelo Edessa"/>
+        <a:font script="Syre" typeface="Estrangelo Edessa"/>
+        <a:font script="Sora" typeface="Nirmala UI"/>
+        <a:font script="Tale" typeface="Microsoft Tai Le"/>
+        <a:font script="Talu" typeface="Microsoft New Tai Lue"/>
+        <a:font script="Tfng" typeface="Ebrima"/>
+      </a:minorFont>
+    </a:fontScheme>
+    <a:fmtScheme name="Office">
+      <a:fillStyleLst>
+        <a:solidFill>
+          <a:schemeClr val="phClr"/>
+        </a:solidFill>
+        <a:gradFill rotWithShape="1">
+          <a:gsLst>
+            <a:gs pos="0">
+              <a:schemeClr val="phClr">
+                <a:lumMod val="110000"/>
+                <a:satMod val="105000"/>
+                <a:tint val="67000"/>
+              </a:schemeClr>
+            </a:gs>
+            <a:gs pos="50000">
+              <a:schemeClr val="phClr">
+                <a:lumMod val="105000"/>
+                <a:satMod val="103000"/>
+                <a:tint val="73000"/>
+              </a:schemeClr>
+            </a:gs>
+            <a:gs pos="100000">
+              <a:schemeClr val="phClr">
+                <a:lumMod val="105000"/>
+                <a:satMod val="109000"/>
+                <a:tint val="81000"/>
+              </a:schemeClr>
+            </a:gs>
+          </a:gsLst>
+          <a:lin ang="5400000" scaled="0"/>
+        </a:gradFill>
+        <a:gradFill rotWithShape="1">
+          <a:gsLst>
+            <a:gs pos="0">
+              <a:schemeClr val="phClr">
+                <a:satMod val="103000"/>
+                <a:lumMod val="102000"/>
+                <a:tint val="94000"/>
+              </a:schemeClr>
+            </a:gs>
+            <a:gs pos="50000">
+              <a:schemeClr val="phClr">
+                <a:satMod val="110000"/>
+                <a:lumMod val="100000"/>
+                <a:shade val="100000"/>
+              </a:schemeClr>
+            </a:gs>
+            <a:gs pos="100000">
+              <a:schemeClr val="phClr">
+                <a:lumMod val="99000"/>
+                <a:satMod val="120000"/>
+                <a:shade val="78000"/>
+              </a:schemeClr>
+            </a:gs>
+          </a:gsLst>
+          <a:lin ang="5400000" scaled="0"/>
+        </a:gradFill>
+      </a:fillStyleLst>
+      <a:lnStyleLst>
+        <a:ln w="12700" cap="flat" cmpd="sng" algn="ctr">
+          <a:solidFill>
+            <a:schemeClr val="phClr"/>
+          </a:solidFill>
+          <a:prstDash val="solid"/>
+          <a:miter lim="800000"/>
+        </a:ln>
+        <a:ln w="19050" cap="flat" cmpd="sng" algn="ctr">
+          <a:solidFill>
+            <a:schemeClr val="phClr"/>
+          </a:solidFill>
+          <a:prstDash val="solid"/>
+          <a:miter lim="800000"/>
+        </a:ln>
+        <a:ln w="25400" cap="flat" cmpd="sng" algn="ctr">
+          <a:solidFill>
+            <a:schemeClr val="phClr"/>
+          </a:solidFill>
+          <a:prstDash val="solid"/>
+          <a:miter lim="800000"/>
+        </a:ln>
+      </a:lnStyleLst>
+      <a:effectStyleLst>
+        <a:effectStyle>
+          <a:effectLst/>
+        </a:effectStyle>
+        <a:effectStyle>
+          <a:effectLst/>
+        </a:effectStyle>
+        <a:effectStyle>
+          <a:effectLst>
+            <a:outerShdw blurRad="57150" dist="19050" dir="5400000" algn="ctr" rotWithShape="0">
+              <a:srgbClr val="000000">
+                <a:alpha val="63000"/>
+              </a:srgbClr>
+            </a:outerShdw>
+          </a:effectLst>
+        </a:effectStyle>
+      </a:effectStyleLst>
+      <a:bgFillStyleLst>
+        <a:solidFill>
+          <a:schemeClr val="phClr"/>
+        </a:solidFill>
+        <a:solidFill>
+          <a:schemeClr val="phClr">
+            <a:tint val="95000"/>
+            <a:satMod val="170000"/>
+          </a:schemeClr>
+        </a:solidFill>
+        <a:gradFill rotWithShape="1">
+          <a:gsLst>
+            <a:gs pos="0">
+              <a:schemeClr val="phClr">
+                <a:tint val="93000"/>
+                <a:satMod val="150000"/>
+                <a:shade val="98000"/>
+                <a:lumMod val="102000"/>
+              </a:schemeClr>
+            </a:gs>
+            <a:gs pos="50000">
+              <a:schemeClr val="phClr">
+                <a:tint val="98000"/>
+                <a:satMod val="130000"/>
+                <a:shade val="90000"/>
+                <a:lumMod val="103000"/>
+              </a:schemeClr>
+            </a:gs>
+            <a:gs pos="100000">
+              <a:schemeClr val="phClr">
+                <a:shade val="63000"/>
+                <a:satMod val="120000"/>
+              </a:schemeClr>
+            </a:gs>
+          </a:gsLst>
+          <a:lin ang="5400000" scaled="0"/>
+        </a:gradFill>
+      </a:bgFillStyleLst>
+    </a:fmtScheme>
+  </a:themeElements>
+  <a:objectDefaults>
+    <a:lnDef>
+      <a:spPr/>
+      <a:bodyPr/>
+      <a:lstStyle/>
+      <a:style>
+        <a:lnRef idx="2">
+          <a:schemeClr val="accent1"/>
+        </a:lnRef>
+        <a:fillRef idx="0">
+          <a:schemeClr val="accent1"/>
+        </a:fillRef>
+        <a:effectRef idx="1">
+          <a:schemeClr val="accent1"/>
+        </a:effectRef>
+        <a:fontRef idx="minor">
+          <a:schemeClr val="tx1"/>
+        </a:fontRef>
+      </a:style>
+    </a:lnDef>
+  </a:objectDefaults>
+  <a:extraClrSchemeLst/>
+  <a:extLst>
+    <a:ext uri="{05A4C25C-085E-4340-85A3-A5531E510DB2}">
+      <thm15:themeFamily xmlns:thm15="http://schemas.microsoft.com/office/thememl/2012/main" name="Office Theme" id="{2E142A2C-CD16-42D6-873A-C26D2A0506FA}" vid="{1BDDFF52-6CD6-40A5-AB3C-68EB2F1E4D0A}"/>
+    </a:ext>
+  </a:extLst>
+</a:theme>
 </file>
</xml_diff>